<commit_message>
docs: chuan hoa thuat ngu (AIoT -> IoT, nghi nga, thiet lap ket noi truoc, pha on dinh/xac minh tu the)
- README, firmware/wearable/README, bao cao .docx, slide .pptx/.html
- Tin nhan Telegram cua cau noi camera K230 doi "AIoT" thanh "IoT"
</commit_message>
<xml_diff>
--- a/docs/reports/Slide_Thuyet_Trinh_Nhom_1.pptx
+++ b/docs/reports/Slide_Thuyet_Trinh_Nhom_1.pptx
@@ -4317,7 +4317,7 @@
                 </a:solidFill>
                 <a:latin typeface="Segoe UI"/>
               </a:rPr>
-              <a:t>UDP • BLE • TLS nóng • Fast-Flush • App</a:t>
+              <a:t>UDP • BLE • TLS dựng sẵn • Fast-Flush • App</a:t>
             </a:r>
           </a:p>
           <a:p>
@@ -6127,7 +6127,7 @@
                 </a:solidFill>
                 <a:latin typeface="Segoe UI"/>
               </a:rPr>
-              <a:t>▸  Bước 1 – Mở ứng viên: </a:t>
+              <a:t>▸  Bước 1 – Phát hiện nghi ngã (fall candidate): </a:t>
             </a:r>
             <a:r>
               <a:rPr sz="1140" b="0" i="0">
@@ -6136,7 +6136,7 @@
                 </a:solidFill>
                 <a:latin typeface="Segoe UI"/>
               </a:rPr>
-              <a:t>Kích hoạt khi tổng gia tốc |a| ≥ 2,0g; lưu vector tư thế trước va chạm before_.</a:t>
+              <a:t>Bắt đầu pha xác minh khi tổng gia tốc |a| ≥ 2,0g; lưu vector tư thế trước va chạm before_.</a:t>
             </a:r>
           </a:p>
           <a:p>
@@ -6189,7 +6189,7 @@
                 </a:solidFill>
                 <a:latin typeface="Segoe UI"/>
               </a:rPr>
-              <a:t>▸  Bước 3 – Pha lắng 1,0 giây: </a:t>
+              <a:t>▸  Bước 3 – Pha ổn định (settling) 1,0 giây: </a:t>
             </a:r>
             <a:r>
               <a:rPr sz="1140" b="0" i="0">
@@ -6220,7 +6220,7 @@
                 </a:solidFill>
                 <a:latin typeface="Segoe UI"/>
               </a:rPr>
-              <a:t>▸  Bước 4 – Quan sát 2,0 giây: </a:t>
+              <a:t>▸  Bước 4 – Pha xác minh tư thế 2,0 giây: </a:t>
             </a:r>
             <a:r>
               <a:rPr sz="1140" b="0" i="0">
@@ -11255,7 +11255,7 @@
                 </a:solidFill>
                 <a:latin typeface="Segoe UI"/>
               </a:rPr>
-              <a:t>Tại mỗi thời điểm chỉ có 1 phiên TLS; khi có báo động, CloudSync đẩy trạng thái alarm trên phiên TLS nóng (Fast-Flush) rồi nhường ngay cho Telegram/Gmail.</a:t>
+              <a:t>Tại mỗi thời điểm chỉ có 1 phiên TLS; khi có báo động, CloudSync đẩy trạng thái alarm trên phiên TLS dựng sẵn (keep-alive, Fast-Flush) rồi nhường ngay cho Telegram/Gmail.</a:t>
             </a:r>
           </a:p>
         </p:txBody>
@@ -12987,7 +12987,7 @@
                           </a:solidFill>
                           <a:latin typeface="Segoe UI"/>
                         </a:rPr>
-                        <a:t>3. Pre-Warm TLS</a:t>
+                        <a:t>3. Thiết lập kết nối trước (pre-warming)</a:t>
                       </a:r>
                     </a:p>
                   </a:txBody>
@@ -13081,7 +13081,7 @@
                           </a:solidFill>
                           <a:latin typeface="Segoe UI"/>
                         </a:rPr>
-                        <a:t>Task notification; PUT alarm trên phiên TLS nóng rồi nhường TlsGate</a:t>
+                        <a:t>Task notification; PUT alarm trên phiên TLS dựng sẵn rồi nhường TlsGate</a:t>
                       </a:r>
                     </a:p>
                   </a:txBody>
@@ -15319,7 +15319,7 @@
                           </a:solidFill>
                           <a:latin typeface="Segoe UI"/>
                         </a:rPr>
-                        <a:t>Fast-Flush: PUT alarm trên phiên TLS nóng → releaseTls() (vẫn 1 phiên TLS)</a:t>
+                        <a:t>Fast-Flush: PUT alarm trên phiên TLS dựng sẵn → releaseTls() (vẫn 1 phiên TLS)</a:t>
                       </a:r>
                     </a:p>
                   </a:txBody>
@@ -27055,7 +27055,7 @@
                           </a:solidFill>
                           <a:latin typeface="Segoe UI"/>
                         </a:rPr>
-                        <a:t>ĐẠT – Tự hủy ứng viên ở Bước 4, không báo động giả</a:t>
+                        <a:t>ĐẠT – Loại bỏ sự kiện nghi ngã ở Bước 4, không báo động giả</a:t>
                       </a:r>
                     </a:p>
                   </a:txBody>
@@ -29226,7 +29226,7 @@
                 </a:solidFill>
                 <a:latin typeface="Segoe UI"/>
               </a:rPr>
-              <a:t>PSRAM tlsCalloc + TlsGate; đường truyền 5 lớp (UDP, BLE không chặn, Pre-Warm TLS, Fast-Flush) và ứng dụng Flutter Android/iOS hợp nhất cảnh báo đa nguồn; 12/12 kịch bản T01–T12 đạt, 69 kiểm thử ứng dụng PASS.</a:t>
+              <a:t>PSRAM tlsCalloc + TlsGate; đường truyền 5 lớp (UDP, BLE không chặn, thiết lập kết nối trước, Fast-Flush) và ứng dụng Flutter Android/iOS hợp nhất cảnh báo đa nguồn; 12/12 kịch bản T01–T12 đạt, 69 kiểm thử ứng dụng PASS.</a:t>
             </a:r>
           </a:p>
         </p:txBody>
@@ -32331,7 +32331,7 @@
                 </a:solidFill>
                 <a:latin typeface="Segoe UI"/>
               </a:rPr>
-              <a:t>pha</a:t>
+              <a:t>pha ổn định 1s</a:t>
             </a:r>
             <a:r>
               <a:rPr sz="1140" b="0" i="0" dirty="0">
@@ -32340,25 +32340,25 @@
                 </a:solidFill>
                 <a:latin typeface="Segoe UI"/>
               </a:rPr>
+              <a:t/>
+            </a:r>
+            <a:r>
+              <a:rPr sz="1140" b="0" i="0" dirty="0" err="1">
+                <a:solidFill>
+                  <a:srgbClr val="1E3A5F"/>
+                </a:solidFill>
+                <a:latin typeface="Segoe UI"/>
+              </a:rPr>
+              <a:t/>
+            </a:r>
+            <a:r>
+              <a:rPr sz="1140" b="0" i="0" dirty="0">
+                <a:solidFill>
+                  <a:srgbClr val="1E3A5F"/>
+                </a:solidFill>
+                <a:latin typeface="Segoe UI"/>
+              </a:rPr>
               <a:t> </a:t>
-            </a:r>
-            <a:r>
-              <a:rPr sz="1140" b="0" i="0" dirty="0" err="1">
-                <a:solidFill>
-                  <a:srgbClr val="1E3A5F"/>
-                </a:solidFill>
-                <a:latin typeface="Segoe UI"/>
-              </a:rPr>
-              <a:t>lắng</a:t>
-            </a:r>
-            <a:r>
-              <a:rPr sz="1140" b="0" i="0" dirty="0">
-                <a:solidFill>
-                  <a:srgbClr val="1E3A5F"/>
-                </a:solidFill>
-                <a:latin typeface="Segoe UI"/>
-              </a:rPr>
-              <a:t> 1s </a:t>
             </a:r>
             <a:r>
               <a:rPr sz="1140" b="0" i="0" dirty="0" err="1">

</xml_diff>

<commit_message>
feat: ma nguon mo (MIT), tach Wi-Fi K230 khoi ma nguon, cap nhat slide va bao cao
- LICENSE MIT (c) 2026 Marine (Tuan Hung); README them muc dong gop
- falldown_detect.py doc SSID/mat khau tu /sdcard/k230_wifi.json (gitignore,
  mau k230_wifi.example.json); thieu file thi bo qua Wi-Fi, van phat hien nga
- Slide HTML: giao dien app moi, ket qua thu phan cung T01-T12, huong phat trien
  da thiet bi, trang cuoi QR repo; bao cao docx/pptx dong bo (82 test, APK/IPA)
</commit_message>
<xml_diff>
--- a/docs/reports/Slide_Thuyet_Trinh_Nhom_1.pptx
+++ b/docs/reports/Slide_Thuyet_Trinh_Nhom_1.pptx
@@ -13399,7 +13399,7 @@
                 </a:solidFill>
                 <a:latin typeface="Segoe UI"/>
               </a:rPr>
-              <a:t>độ trễ là giá trị thiết kế/mục tiêu; số đo thực tế trên phần cứng sẽ bổ sung.</a:t>
+              <a:t>độ trễ là giá trị thiết kế/mục tiêu.</a:t>
             </a:r>
           </a:p>
         </p:txBody>
@@ -18124,7 +18124,7 @@
                 </a:solidFill>
                 <a:latin typeface="Segoe UI"/>
               </a:rPr>
-              <a:t>Flutter 3.47.9 / Dart 3.13.7 – một mã nguồn cho Android (APK) và iOS (IPA cài bằng Sideloadly)</a:t>
+              <a:t>Flutter 3.47.9 / Dart 3.13.7 – giao diện tối giản kiểu iOS, một mã nguồn cho Android (APK) và iOS (IPA cài bằng Sideloadly)</a:t>
             </a:r>
           </a:p>
         </p:txBody>
@@ -18719,7 +18719,7 @@
                 </a:solidFill>
                 <a:latin typeface="Segoe UI"/>
               </a:rPr>
-              <a:t>~7 000 dòng</a:t>
+              <a:t>~8 900 dòng</a:t>
             </a:r>
           </a:p>
           <a:p>
@@ -18975,7 +18975,7 @@
                 </a:solidFill>
                 <a:latin typeface="Segoe UI"/>
               </a:rPr>
-              <a:t>4 tab</a:t>
+              <a:t>3 tab</a:t>
             </a:r>
           </a:p>
           <a:p>
@@ -19010,7 +19010,7 @@
                 </a:solidFill>
                 <a:latin typeface="Segoe UI"/>
               </a:rPr>
-              <a:t>Vòng đeo • Camera • Nhật ký • Cài đặt &amp; SOS</a:t>
+              <a:t>Tổng quan • Lịch sử • Cài đặt</a:t>
             </a:r>
           </a:p>
         </p:txBody>
@@ -19097,7 +19097,7 @@
                 </a:solidFill>
                 <a:latin typeface="Segoe UI"/>
               </a:rPr>
-              <a:t>69 PASS</a:t>
+              <a:t>82 PASS</a:t>
             </a:r>
           </a:p>
           <a:p>
@@ -19116,7 +19116,7 @@
                 </a:solidFill>
                 <a:latin typeface="Segoe UI"/>
               </a:rPr>
-              <a:t>flutter test (9 tệp)</a:t>
+              <a:t>flutter test (10 tệp)</a:t>
             </a:r>
           </a:p>
           <a:p>
@@ -19184,227 +19184,13 @@
       </p:sp>
       <p:sp>
         <p:nvSpPr>
-          <p:cNvPr id="24" name="Rectangle 23"/>
-          <p:cNvSpPr/>
-          <p:nvPr/>
-        </p:nvSpPr>
-        <p:spPr>
-          <a:xfrm>
-            <a:off x="594360" y="2980944"/>
-            <a:ext cx="45720" cy="3264408"/>
-          </a:xfrm>
-          <a:prstGeom prst="rect">
-            <a:avLst/>
-          </a:prstGeom>
-          <a:solidFill>
-            <a:srgbClr val="607D9F"/>
-          </a:solidFill>
-          <a:ln>
-            <a:noFill/>
-          </a:ln>
-          <a:effectLst/>
-        </p:spPr>
-        <p:style>
-          <a:lnRef idx="1">
-            <a:schemeClr val="accent1"/>
-          </a:lnRef>
-          <a:fillRef idx="3">
-            <a:schemeClr val="accent1"/>
-          </a:fillRef>
-          <a:effectRef idx="0">
-            <a:schemeClr val="accent1"/>
-          </a:effectRef>
-          <a:fontRef idx="minor">
-            <a:schemeClr val="lt1"/>
-          </a:fontRef>
-        </p:style>
-        <p:txBody>
-          <a:bodyPr rtlCol="0" anchor="ctr"/>
-          <a:lstStyle/>
-          <a:p>
-            <a:pPr algn="ctr"/>
-            <a:endParaRPr/>
-          </a:p>
-        </p:txBody>
-      </p:sp>
-      <p:sp>
-        <p:nvSpPr>
-          <p:cNvPr id="25" name="TextBox 24"/>
-          <p:cNvSpPr txBox="1"/>
-          <p:nvPr/>
-        </p:nvSpPr>
-        <p:spPr>
-          <a:xfrm>
-            <a:off x="758952" y="2944368"/>
-            <a:ext cx="5166359" cy="3337560"/>
-          </a:xfrm>
-          <a:prstGeom prst="rect">
-            <a:avLst/>
-          </a:prstGeom>
-          <a:noFill/>
-        </p:spPr>
-        <p:txBody>
-          <a:bodyPr wrap="square" lIns="18288" tIns="0" rIns="18288" bIns="0">
-            <a:spAutoFit/>
-          </a:bodyPr>
-          <a:lstStyle/>
-          <a:p>
-            <a:pPr>
-              <a:lnSpc>
-                <a:spcPct val="115000"/>
-              </a:lnSpc>
-              <a:spcBef>
-                <a:spcPts val="0"/>
-              </a:spcBef>
-              <a:spcAft>
-                <a:spcPts val="500"/>
-              </a:spcAft>
-            </a:pPr>
-            <a:r>
-              <a:rPr sz="1320" b="1" i="0">
-                <a:solidFill>
-                  <a:srgbClr val="607D9F"/>
-                </a:solidFill>
-                <a:latin typeface="Segoe UI"/>
-              </a:rPr>
-              <a:t>KẾT NỐI &amp; BẢO MẬT</a:t>
-            </a:r>
-          </a:p>
-          <a:p>
-            <a:pPr>
-              <a:lnSpc>
-                <a:spcPct val="118000"/>
-              </a:lnSpc>
-              <a:spcBef>
-                <a:spcPts val="200"/>
-              </a:spcBef>
-              <a:spcAft>
-                <a:spcPts val="400"/>
-              </a:spcAft>
-            </a:pPr>
-            <a:r>
-              <a:rPr sz="1160" b="1" i="0">
-                <a:solidFill>
-                  <a:srgbClr val="0A2540"/>
-                </a:solidFill>
-                <a:latin typeface="Segoe UI"/>
-              </a:rPr>
-              <a:t>▸  Firebase REST + SSE (không SDK): </a:t>
-            </a:r>
-            <a:r>
-              <a:rPr sz="1140" b="0" i="0">
-                <a:solidFill>
-                  <a:srgbClr val="1E3A5F"/>
-                </a:solidFill>
-                <a:latin typeface="Segoe UI"/>
-              </a:rPr>
-              <a:t>tự làm mới idToken, quyền owner/viewer, nối lại backoff 1→30 s.</a:t>
-            </a:r>
-          </a:p>
-          <a:p>
-            <a:pPr>
-              <a:lnSpc>
-                <a:spcPct val="118000"/>
-              </a:lnSpc>
-              <a:spcBef>
-                <a:spcPts val="200"/>
-              </a:spcBef>
-              <a:spcAft>
-                <a:spcPts val="400"/>
-              </a:spcAft>
-            </a:pPr>
-            <a:r>
-              <a:rPr sz="1160" b="1" i="0">
-                <a:solidFill>
-                  <a:srgbClr val="0A2540"/>
-                </a:solidFill>
-                <a:latin typeface="Segoe UI"/>
-              </a:rPr>
-              <a:t>▸  Web Portal nội mạng: </a:t>
-            </a:r>
-            <a:r>
-              <a:rPr sz="1140" b="0" i="0">
-                <a:solidFill>
-                  <a:srgbClr val="1E3A5F"/>
-                </a:solidFill>
-                <a:latin typeface="Segoe UI"/>
-              </a:rPr>
-              <a:t>baonga.local / IP LAN / hotspot 192.168.4.1; X-Requested-With, Basic Auth.</a:t>
-            </a:r>
-          </a:p>
-          <a:p>
-            <a:pPr>
-              <a:lnSpc>
-                <a:spcPct val="118000"/>
-              </a:lnSpc>
-              <a:spcBef>
-                <a:spcPts val="200"/>
-              </a:spcBef>
-              <a:spcAft>
-                <a:spcPts val="400"/>
-              </a:spcAft>
-            </a:pPr>
-            <a:r>
-              <a:rPr sz="1160" b="1" i="0">
-                <a:solidFill>
-                  <a:srgbClr val="0A2540"/>
-                </a:solidFill>
-                <a:latin typeface="Segoe UI"/>
-              </a:rPr>
-              <a:t>▸  Ghép Camera bằng mã QR: </a:t>
-            </a:r>
-            <a:r>
-              <a:rPr sz="1140" b="0" i="0">
-                <a:solidFill>
-                  <a:srgbClr val="1E3A5F"/>
-                </a:solidFill>
-                <a:latin typeface="Segoe UI"/>
-              </a:rPr>
-              <a:t>cbn://pair?id=CBC-…&amp;key=…; khóa = HMAC-SHA256(MASTER_KEY, MAC).</a:t>
-            </a:r>
-          </a:p>
-          <a:p>
-            <a:pPr>
-              <a:lnSpc>
-                <a:spcPct val="118000"/>
-              </a:lnSpc>
-              <a:spcBef>
-                <a:spcPts val="200"/>
-              </a:spcBef>
-              <a:spcAft>
-                <a:spcPts val="400"/>
-              </a:spcAft>
-            </a:pPr>
-            <a:r>
-              <a:rPr sz="1160" b="1" i="0">
-                <a:solidFill>
-                  <a:srgbClr val="0A2540"/>
-                </a:solidFill>
-                <a:latin typeface="Segoe UI"/>
-              </a:rPr>
-              <a:t>▸  Xác thực hỏi – đáp BLE: </a:t>
-            </a:r>
-            <a:r>
-              <a:rPr sz="1140" b="0" i="0">
-                <a:solidFill>
-                  <a:srgbClr val="1E3A5F"/>
-                </a:solidFill>
-                <a:latin typeface="Segoe UI"/>
-              </a:rPr>
-              <a:t>nonce 24 ký tự → 16 byte đầu HMAC-SHA256 (32 HEX hoa), khớp firmware.</a:t>
-            </a:r>
-          </a:p>
-        </p:txBody>
-      </p:sp>
-      <p:sp>
-        <p:nvSpPr>
           <p:cNvPr id="26" name="Rectangle 25"/>
           <p:cNvSpPr/>
           <p:nvPr/>
         </p:nvSpPr>
         <p:spPr>
           <a:xfrm>
-            <a:off x="6217920" y="2980944"/>
+            <a:off x="6967728" y="2980944"/>
             <a:ext cx="45720" cy="3264408"/>
           </a:xfrm>
           <a:prstGeom prst="rect">
@@ -19449,8 +19235,8 @@
         </p:nvSpPr>
         <p:spPr>
           <a:xfrm>
-            <a:off x="6382512" y="2944368"/>
-            <a:ext cx="5349240" cy="2389565"/>
+            <a:off x="7132320" y="2944368"/>
+            <a:ext cx="4617720" cy="2389565"/>
           </a:xfrm>
           <a:prstGeom prst="rect">
             <a:avLst/>
@@ -19481,7 +19267,7 @@
                 </a:solidFill>
                 <a:latin typeface="Segoe UI"/>
               </a:rPr>
-              <a:t>TRIỂN KHAI &amp; CI/CD</a:t>
+              <a:t>GIAO DIỆN MỚI &amp; TÍNH NĂNG</a:t>
             </a:r>
             <a:endParaRPr lang="en-US" sz="1320" b="1" i="0" dirty="0">
               <a:solidFill>
@@ -19509,7 +19295,7 @@
                 </a:solidFill>
                 <a:latin typeface="Segoe UI"/>
               </a:rPr>
-              <a:t>▸  Android: </a:t>
+              <a:t>▸  Tổng quan: </a:t>
             </a:r>
             <a:r>
               <a:rPr sz="1140" b="0" i="0" dirty="0">
@@ -19518,7 +19304,7 @@
                 </a:solidFill>
                 <a:latin typeface="Segoe UI"/>
               </a:rPr>
-              <a:t>Foreground Service connectedDevice; báo động full-screen, âm lặp FLAG_INSISTENT; SOS qua tel:.</a:t>
+              <a:t>trạng thái theo ưu tiên báo động › không cử động › mất tín hiệu › đang kết nối › an toàn; camera 16:9, vòng đeo kèm % pin.</a:t>
             </a:r>
           </a:p>
           <a:p>
@@ -19540,7 +19326,7 @@
                 </a:solidFill>
                 <a:latin typeface="Segoe UI"/>
               </a:rPr>
-              <a:t>▸  iOS: </a:t>
+              <a:t>▸  Báo động: </a:t>
             </a:r>
             <a:r>
               <a:rPr sz="1140" b="0" i="0" dirty="0">
@@ -19549,7 +19335,7 @@
                 </a:solidFill>
                 <a:latin typeface="Segoe UI"/>
               </a:rPr>
-              <a:t>entitlements rỗng, nền CoreBluetooth, nhận UDP qua unicast; Keychain có dự phòng SharedPreferences.</a:t>
+              <a:t>nền đỏ toàn màn hình, «Gọi cấp cứu 115» / «Đã kiểm tra, tắt chuông»; nhãn đa nguồn khi vòng đeo và camera cùng xác nhận.</a:t>
             </a:r>
           </a:p>
           <a:p>
@@ -19571,7 +19357,7 @@
                 </a:solidFill>
                 <a:latin typeface="Segoe UI"/>
               </a:rPr>
-              <a:t>▸  Màn hình báo động: </a:t>
+              <a:t>▸  Lịch sử: </a:t>
             </a:r>
             <a:r>
               <a:rPr sz="1140" b="0" i="0" dirty="0">
@@ -19580,7 +19366,7 @@
                 </a:solidFill>
                 <a:latin typeface="Segoe UI"/>
               </a:rPr>
-              <a:t>«GỌI CẤP CỨU / NGƯỜI THÂN NGAY» và «ĐÃ KIỂM TRA – TẮT CHUÔNG».</a:t>
+              <a:t>lọc Tất cả | Ngã | Không cử động; Chi tiết sự cố có «Thông tin kỹ thuật» (kênh UDP/BLE/Cloud).</a:t>
             </a:r>
           </a:p>
           <a:p>
@@ -19602,7 +19388,7 @@
                 </a:solidFill>
                 <a:latin typeface="Segoe UI"/>
               </a:rPr>
-              <a:t>▸  CI/CD GitHub Actions: </a:t>
+              <a:t>▸  Mới: </a:t>
             </a:r>
             <a:r>
               <a:rPr sz="1140" b="0" i="0" dirty="0">
@@ -19611,7 +19397,349 @@
                 </a:solidFill>
                 <a:latin typeface="Segoe UI"/>
               </a:rPr>
-              <a:t>build-android (analyze, test, APK) song song build-ios (--no-codesign → IPA).</a:t>
+              <a:t>mất tín hiệu vòng đeo sau 75 s (khớp web), % pin từ mV, tên người được theo dõi (chỉ owner ghi).</a:t>
+            </a:r>
+          </a:p>
+          <a:p>
+            <a:pPr>
+              <a:lnSpc>
+                <a:spcPct val="115000"/>
+              </a:lnSpc>
+              <a:spcBef>
+                <a:spcPts val="0"/>
+              </a:spcBef>
+              <a:spcAft>
+                <a:spcPts val="500"/>
+              </a:spcAft>
+            </a:pPr>
+            <a:r>
+              <a:rPr sz="1160" b="1" i="0" dirty="0">
+                <a:solidFill>
+                  <a:srgbClr val="0A2540"/>
+                </a:solidFill>
+                <a:latin typeface="Segoe UI"/>
+              </a:rPr>
+              <a:t>▸  Kết nối: </a:t>
+            </a:r>
+            <a:r>
+              <a:rPr sz="1140" b="0" i="0" dirty="0">
+                <a:solidFill>
+                  <a:srgbClr val="1E3A5F"/>
+                </a:solidFill>
+                <a:latin typeface="Segoe UI"/>
+              </a:rPr>
+              <a:t>Firebase REST + SSE, Web Portal, BLE QR + HMAC; Android Foreground Service, iOS sideload; CI GitHub Actions.</a:t>
+            </a:r>
+          </a:p>
+        </p:txBody>
+      </p:sp>
+      <p:pic>
+        <p:nvPicPr>
+          <p:cNvPr id="36" name="App overview_safe" descr="s_overview_safe.png"/>
+          <p:cNvPicPr>
+            <a:picLocks noChangeAspect="1"/>
+          </p:cNvPicPr>
+          <p:nvPr/>
+        </p:nvPicPr>
+        <p:blipFill>
+          <a:blip r:embed="rId3"/>
+          <a:stretch>
+            <a:fillRect/>
+          </a:stretch>
+        </p:blipFill>
+        <p:spPr>
+          <a:xfrm>
+            <a:off x="685800" y="2926080"/>
+            <a:ext cx="1288718" cy="2788920"/>
+          </a:xfrm>
+          <a:prstGeom prst="rect">
+            <a:avLst/>
+          </a:prstGeom>
+          <a:ln w="9525">
+            <a:solidFill>
+              <a:srgbClr val="C5CCD8"/>
+            </a:solidFill>
+          </a:ln>
+        </p:spPr>
+      </p:pic>
+      <p:sp>
+        <p:nvSpPr>
+          <p:cNvPr id="16" name="TextBox 15"/>
+          <p:cNvSpPr txBox="1"/>
+          <p:nvPr/>
+        </p:nvSpPr>
+        <p:spPr>
+          <a:xfrm>
+            <a:off x="594360" y="5751576"/>
+            <a:ext cx="1471598" cy="256032"/>
+          </a:xfrm>
+          <a:prstGeom prst="rect">
+            <a:avLst/>
+          </a:prstGeom>
+          <a:noFill/>
+        </p:spPr>
+        <p:txBody>
+          <a:bodyPr wrap="square" lIns="18288" tIns="18288" rIns="18288" bIns="18288" anchor="ctr">
+            <a:spAutoFit/>
+          </a:bodyPr>
+          <a:lstStyle/>
+          <a:p>
+            <a:pPr algn="ctr">
+              <a:lnSpc>
+                <a:spcPct val="120000"/>
+              </a:lnSpc>
+            </a:pPr>
+            <a:r>
+              <a:rPr sz="980" b="0" i="0">
+                <a:solidFill>
+                  <a:srgbClr val="607D9F"/>
+                </a:solidFill>
+                <a:latin typeface="Segoe UI"/>
+              </a:rPr>
+              <a:t>Tổng quan</a:t>
+            </a:r>
+          </a:p>
+        </p:txBody>
+      </p:sp>
+      <p:pic>
+        <p:nvPicPr>
+          <p:cNvPr id="37" name="App alarm" descr="s_alarm.png"/>
+          <p:cNvPicPr>
+            <a:picLocks noChangeAspect="1"/>
+          </p:cNvPicPr>
+          <p:nvPr/>
+        </p:nvPicPr>
+        <p:blipFill>
+          <a:blip r:embed="rId4"/>
+          <a:stretch>
+            <a:fillRect/>
+          </a:stretch>
+        </p:blipFill>
+        <p:spPr>
+          <a:xfrm>
+            <a:off x="2175686" y="2926080"/>
+            <a:ext cx="1288718" cy="2788920"/>
+          </a:xfrm>
+          <a:prstGeom prst="rect">
+            <a:avLst/>
+          </a:prstGeom>
+          <a:ln w="9525">
+            <a:solidFill>
+              <a:srgbClr val="C5CCD8"/>
+            </a:solidFill>
+          </a:ln>
+        </p:spPr>
+      </p:pic>
+      <p:sp>
+        <p:nvSpPr>
+          <p:cNvPr id="16" name="TextBox 15"/>
+          <p:cNvSpPr txBox="1"/>
+          <p:nvPr/>
+        </p:nvSpPr>
+        <p:spPr>
+          <a:xfrm>
+            <a:off x="2084246" y="5751576"/>
+            <a:ext cx="1471598" cy="256032"/>
+          </a:xfrm>
+          <a:prstGeom prst="rect">
+            <a:avLst/>
+          </a:prstGeom>
+          <a:noFill/>
+        </p:spPr>
+        <p:txBody>
+          <a:bodyPr wrap="square" lIns="18288" tIns="18288" rIns="18288" bIns="18288" anchor="ctr">
+            <a:spAutoFit/>
+          </a:bodyPr>
+          <a:lstStyle/>
+          <a:p>
+            <a:pPr algn="ctr">
+              <a:lnSpc>
+                <a:spcPct val="120000"/>
+              </a:lnSpc>
+            </a:pPr>
+            <a:r>
+              <a:rPr sz="980" b="0" i="0">
+                <a:solidFill>
+                  <a:srgbClr val="607D9F"/>
+                </a:solidFill>
+                <a:latin typeface="Segoe UI"/>
+              </a:rPr>
+              <a:t>Báo động</a:t>
+            </a:r>
+          </a:p>
+        </p:txBody>
+      </p:sp>
+      <p:pic>
+        <p:nvPicPr>
+          <p:cNvPr id="38" name="App history" descr="s_history.png"/>
+          <p:cNvPicPr>
+            <a:picLocks noChangeAspect="1"/>
+          </p:cNvPicPr>
+          <p:nvPr/>
+        </p:nvPicPr>
+        <p:blipFill>
+          <a:blip r:embed="rId5"/>
+          <a:stretch>
+            <a:fillRect/>
+          </a:stretch>
+        </p:blipFill>
+        <p:spPr>
+          <a:xfrm>
+            <a:off x="3665573" y="2926080"/>
+            <a:ext cx="1288718" cy="2788920"/>
+          </a:xfrm>
+          <a:prstGeom prst="rect">
+            <a:avLst/>
+          </a:prstGeom>
+          <a:ln w="9525">
+            <a:solidFill>
+              <a:srgbClr val="C5CCD8"/>
+            </a:solidFill>
+          </a:ln>
+        </p:spPr>
+      </p:pic>
+      <p:sp>
+        <p:nvSpPr>
+          <p:cNvPr id="16" name="TextBox 15"/>
+          <p:cNvSpPr txBox="1"/>
+          <p:nvPr/>
+        </p:nvSpPr>
+        <p:spPr>
+          <a:xfrm>
+            <a:off x="3574133" y="5751576"/>
+            <a:ext cx="1471598" cy="256032"/>
+          </a:xfrm>
+          <a:prstGeom prst="rect">
+            <a:avLst/>
+          </a:prstGeom>
+          <a:noFill/>
+        </p:spPr>
+        <p:txBody>
+          <a:bodyPr wrap="square" lIns="18288" tIns="18288" rIns="18288" bIns="18288" anchor="ctr">
+            <a:spAutoFit/>
+          </a:bodyPr>
+          <a:lstStyle/>
+          <a:p>
+            <a:pPr algn="ctr">
+              <a:lnSpc>
+                <a:spcPct val="120000"/>
+              </a:lnSpc>
+            </a:pPr>
+            <a:r>
+              <a:rPr sz="980" b="0" i="0">
+                <a:solidFill>
+                  <a:srgbClr val="607D9F"/>
+                </a:solidFill>
+                <a:latin typeface="Segoe UI"/>
+              </a:rPr>
+              <a:t>Lịch sử</a:t>
+            </a:r>
+          </a:p>
+        </p:txBody>
+      </p:sp>
+      <p:pic>
+        <p:nvPicPr>
+          <p:cNvPr id="39" name="App incident_detail" descr="s_incident_detail.png"/>
+          <p:cNvPicPr>
+            <a:picLocks noChangeAspect="1"/>
+          </p:cNvPicPr>
+          <p:nvPr/>
+        </p:nvPicPr>
+        <p:blipFill>
+          <a:blip r:embed="rId6"/>
+          <a:stretch>
+            <a:fillRect/>
+          </a:stretch>
+        </p:blipFill>
+        <p:spPr>
+          <a:xfrm>
+            <a:off x="5155460" y="2926080"/>
+            <a:ext cx="1288718" cy="2788920"/>
+          </a:xfrm>
+          <a:prstGeom prst="rect">
+            <a:avLst/>
+          </a:prstGeom>
+          <a:ln w="9525">
+            <a:solidFill>
+              <a:srgbClr val="C5CCD8"/>
+            </a:solidFill>
+          </a:ln>
+        </p:spPr>
+      </p:pic>
+      <p:sp>
+        <p:nvSpPr>
+          <p:cNvPr id="16" name="TextBox 15"/>
+          <p:cNvSpPr txBox="1"/>
+          <p:nvPr/>
+        </p:nvSpPr>
+        <p:spPr>
+          <a:xfrm>
+            <a:off x="5064020" y="5751576"/>
+            <a:ext cx="1471598" cy="256032"/>
+          </a:xfrm>
+          <a:prstGeom prst="rect">
+            <a:avLst/>
+          </a:prstGeom>
+          <a:noFill/>
+        </p:spPr>
+        <p:txBody>
+          <a:bodyPr wrap="square" lIns="18288" tIns="18288" rIns="18288" bIns="18288" anchor="ctr">
+            <a:spAutoFit/>
+          </a:bodyPr>
+          <a:lstStyle/>
+          <a:p>
+            <a:pPr algn="ctr">
+              <a:lnSpc>
+                <a:spcPct val="120000"/>
+              </a:lnSpc>
+            </a:pPr>
+            <a:r>
+              <a:rPr sz="980" b="0" i="0">
+                <a:solidFill>
+                  <a:srgbClr val="607D9F"/>
+                </a:solidFill>
+                <a:latin typeface="Segoe UI"/>
+              </a:rPr>
+              <a:t>Chi tiết sự cố</a:t>
+            </a:r>
+          </a:p>
+        </p:txBody>
+      </p:sp>
+      <p:sp>
+        <p:nvSpPr>
+          <p:cNvPr id="16" name="TextBox 15"/>
+          <p:cNvSpPr txBox="1"/>
+          <p:nvPr/>
+        </p:nvSpPr>
+        <p:spPr>
+          <a:xfrm>
+            <a:off x="594360" y="6025896"/>
+            <a:ext cx="5941259" cy="256032"/>
+          </a:xfrm>
+          <a:prstGeom prst="rect">
+            <a:avLst/>
+          </a:prstGeom>
+          <a:noFill/>
+        </p:spPr>
+        <p:txBody>
+          <a:bodyPr wrap="square" lIns="18288" tIns="18288" rIns="18288" bIns="18288" anchor="ctr">
+            <a:spAutoFit/>
+          </a:bodyPr>
+          <a:lstStyle/>
+          <a:p>
+            <a:pPr algn="ctr">
+              <a:lnSpc>
+                <a:spcPct val="120000"/>
+              </a:lnSpc>
+            </a:pPr>
+            <a:r>
+              <a:rPr sz="980" b="0" i="1">
+                <a:solidFill>
+                  <a:srgbClr val="607D9F"/>
+                </a:solidFill>
+                <a:latin typeface="Segoe UI"/>
+              </a:rPr>
+              <a:t>Hình 3.6 – 3.7. Ảnh chụp màn hình kết xuất từ mã nguồn app (dữ liệu minh họa)</a:t>
             </a:r>
           </a:p>
         </p:txBody>
@@ -20890,7 +21018,7 @@
                 </a:solidFill>
                 <a:latin typeface="Segoe UI"/>
               </a:rPr>
-              <a:t>Hình 3.6. Dạng sóng gia tốc, vận tốc góc và góc lệch tư thế qua 5 pha té ngã</a:t>
+              <a:t>Hình 3.9. Dạng sóng gia tốc, vận tốc góc và góc lệch tư thế qua 5 pha té ngã</a:t>
             </a:r>
           </a:p>
         </p:txBody>
@@ -22065,7 +22193,7 @@
                 </a:solidFill>
                 <a:latin typeface="Segoe UI"/>
               </a:rPr>
-              <a:t>Đã kiểm chứng trên máy phát triển; chưa đo trên điện thoại/phần cứng thật – số đo độ trễ sẽ bổ sung</a:t>
+              <a:t>Kiểm thử tự động trên máy phát triển; ứng dụng đã chạy trên điện thoại thật – bảng độ trễ ghi giá trị thiết kế</a:t>
             </a:r>
           </a:p>
         </p:txBody>
@@ -22627,9 +22755,8 @@
                 <a:tableStyleId>{5C22544A-7EE6-4342-B048-85BDC9FD1C3A}</a:tableStyleId>
               </a:tblPr>
               <a:tblGrid>
-                <a:gridCol w="1965960"/>
-                <a:gridCol w="3291840"/>
-                <a:gridCol w="1645920"/>
+                <a:gridCol w="2300000"/>
+                <a:gridCol w="4603720"/>
               </a:tblGrid>
               <a:tr h="571500">
                 <a:tc>
@@ -22669,29 +22796,6 @@
                           <a:latin typeface="Segoe UI"/>
                         </a:rPr>
                         <a:t>Giá trị thiết kế / mục tiêu</a:t>
-                      </a:r>
-                    </a:p>
-                  </a:txBody>
-                  <a:tcPr anchor="ctr">
-                    <a:solidFill>
-                      <a:srgbClr val="0D47A1"/>
-                    </a:solidFill>
-                  </a:tcPr>
-                </a:tc>
-                <a:tc>
-                  <a:txBody>
-                    <a:bodyPr/>
-                    <a:lstStyle/>
-                    <a:p>
-                      <a:pPr algn="l"/>
-                      <a:r>
-                        <a:rPr sz="1050" b="1" i="0">
-                          <a:solidFill>
-                            <a:srgbClr val="FFFFFF"/>
-                          </a:solidFill>
-                          <a:latin typeface="Segoe UI"/>
-                        </a:rPr>
-                        <a:t>Đo thực tế</a:t>
                       </a:r>
                     </a:p>
                   </a:txBody>
@@ -22749,29 +22853,6 @@
                     </a:solidFill>
                   </a:tcPr>
                 </a:tc>
-                <a:tc>
-                  <a:txBody>
-                    <a:bodyPr/>
-                    <a:lstStyle/>
-                    <a:p>
-                      <a:pPr algn="l"/>
-                      <a:r>
-                        <a:rPr sz="1050" b="0" i="0">
-                          <a:solidFill>
-                            <a:srgbClr val="1E3A5F"/>
-                          </a:solidFill>
-                          <a:latin typeface="Segoe UI"/>
-                        </a:rPr>
-                        <a:t>Sẽ bổ sung</a:t>
-                      </a:r>
-                    </a:p>
-                  </a:txBody>
-                  <a:tcPr anchor="ctr">
-                    <a:solidFill>
-                      <a:srgbClr val="EBF4FF"/>
-                    </a:solidFill>
-                  </a:tcPr>
-                </a:tc>
               </a:tr>
               <a:tr h="603504">
                 <a:tc>
@@ -22811,29 +22892,6 @@
                           <a:latin typeface="Segoe UI"/>
                         </a:rPr>
                         <a:t>Lần đầu ~0 ms sau khi nhận FALL</a:t>
-                      </a:r>
-                    </a:p>
-                  </a:txBody>
-                  <a:tcPr anchor="ctr">
-                    <a:solidFill>
-                      <a:srgbClr val="FFFFFF"/>
-                    </a:solidFill>
-                  </a:tcPr>
-                </a:tc>
-                <a:tc>
-                  <a:txBody>
-                    <a:bodyPr/>
-                    <a:lstStyle/>
-                    <a:p>
-                      <a:pPr algn="l"/>
-                      <a:r>
-                        <a:rPr sz="1050" b="0" i="0">
-                          <a:solidFill>
-                            <a:srgbClr val="1E3A5F"/>
-                          </a:solidFill>
-                          <a:latin typeface="Segoe UI"/>
-                        </a:rPr>
-                        <a:t>Sẽ bổ sung</a:t>
                       </a:r>
                     </a:p>
                   </a:txBody>
@@ -22891,29 +22949,6 @@
                     </a:solidFill>
                   </a:tcPr>
                 </a:tc>
-                <a:tc>
-                  <a:txBody>
-                    <a:bodyPr/>
-                    <a:lstStyle/>
-                    <a:p>
-                      <a:pPr algn="l"/>
-                      <a:r>
-                        <a:rPr sz="1050" b="0" i="0">
-                          <a:solidFill>
-                            <a:srgbClr val="1E3A5F"/>
-                          </a:solidFill>
-                          <a:latin typeface="Segoe UI"/>
-                        </a:rPr>
-                        <a:t>Sẽ bổ sung</a:t>
-                      </a:r>
-                    </a:p>
-                  </a:txBody>
-                  <a:tcPr anchor="ctr">
-                    <a:solidFill>
-                      <a:srgbClr val="EBF4FF"/>
-                    </a:solidFill>
-                  </a:tcPr>
-                </a:tc>
               </a:tr>
               <a:tr h="603504">
                 <a:tc>
@@ -22953,29 +22988,6 @@
                           <a:latin typeface="Segoe UI"/>
                         </a:rPr>
                         <a:t>Chu kỳ hỏi /api/status 2 s</a:t>
-                      </a:r>
-                    </a:p>
-                  </a:txBody>
-                  <a:tcPr anchor="ctr">
-                    <a:solidFill>
-                      <a:srgbClr val="FFFFFF"/>
-                    </a:solidFill>
-                  </a:tcPr>
-                </a:tc>
-                <a:tc>
-                  <a:txBody>
-                    <a:bodyPr/>
-                    <a:lstStyle/>
-                    <a:p>
-                      <a:pPr algn="l"/>
-                      <a:r>
-                        <a:rPr sz="1050" b="0" i="0">
-                          <a:solidFill>
-                            <a:srgbClr val="1E3A5F"/>
-                          </a:solidFill>
-                          <a:latin typeface="Segoe UI"/>
-                        </a:rPr>
-                        <a:t>Sẽ bổ sung</a:t>
                       </a:r>
                     </a:p>
                   </a:txBody>
@@ -23033,29 +23045,6 @@
                     </a:solidFill>
                   </a:tcPr>
                 </a:tc>
-                <a:tc>
-                  <a:txBody>
-                    <a:bodyPr/>
-                    <a:lstStyle/>
-                    <a:p>
-                      <a:pPr algn="l"/>
-                      <a:r>
-                        <a:rPr sz="1050" b="0" i="0">
-                          <a:solidFill>
-                            <a:srgbClr val="1E3A5F"/>
-                          </a:solidFill>
-                          <a:latin typeface="Segoe UI"/>
-                        </a:rPr>
-                        <a:t>Sẽ bổ sung</a:t>
-                      </a:r>
-                    </a:p>
-                  </a:txBody>
-                  <a:tcPr anchor="ctr">
-                    <a:solidFill>
-                      <a:srgbClr val="EBF4FF"/>
-                    </a:solidFill>
-                  </a:tcPr>
-                </a:tc>
               </a:tr>
               <a:tr h="603504">
                 <a:tc>
@@ -23104,29 +23093,6 @@
                     </a:solidFill>
                   </a:tcPr>
                 </a:tc>
-                <a:tc>
-                  <a:txBody>
-                    <a:bodyPr/>
-                    <a:lstStyle/>
-                    <a:p>
-                      <a:pPr algn="l"/>
-                      <a:r>
-                        <a:rPr sz="1050" b="0" i="0">
-                          <a:solidFill>
-                            <a:srgbClr val="1E3A5F"/>
-                          </a:solidFill>
-                          <a:latin typeface="Segoe UI"/>
-                        </a:rPr>
-                        <a:t>Sẽ bổ sung</a:t>
-                      </a:r>
-                    </a:p>
-                  </a:txBody>
-                  <a:tcPr anchor="ctr">
-                    <a:solidFill>
-                      <a:srgbClr val="FFFFFF"/>
-                    </a:solidFill>
-                  </a:tcPr>
-                </a:tc>
               </a:tr>
             </a:tbl>
           </a:graphicData>
@@ -23248,7 +23214,7 @@
                 </a:solidFill>
                 <a:latin typeface="Segoe UI"/>
               </a:rPr>
-              <a:t>analyze 0 vấn đề; 69 kiểm thử / 9 tệp PASS (HMAC, UDP, AlertFusionEngine, MJPEG, SSE, UI).</a:t>
+              <a:t>analyze 0 vấn đề; 82 kiểm thử / 10 tệp PASS (HMAC, UDP, AlertFusionEngine, MJPEG, SSE, UI).</a:t>
             </a:r>
           </a:p>
           <a:p>
@@ -23372,7 +23338,7 @@
                 </a:solidFill>
                 <a:latin typeface="Segoe UI"/>
               </a:rPr>
-              <a:t>arm64-v8a 25,2 MB; armeabi-v7a 21,2 MB; x86_64 27,7 MB; gộp 68,1 MB.</a:t>
+              <a:t>arm64-v8a 25,5 MB; armeabi-v7a 21,5 MB; x86_64 27,9 MB; gộp 68,5 MB; IPA (app iOS) 7,9 MB.</a:t>
             </a:r>
           </a:p>
         </p:txBody>
@@ -25466,7 +25432,7 @@
               </a:rPr>
               <a:t>• Web baonga.local, Firebase, Telegram &amp; Gmail.
 • «Thời gian vàng» 5 lớp &amp; App «Báo Ngã IoT».
-• Unit Test C++17, 69 kiểm thử app, 12 kịch bản T01–T12.</a:t>
+• Unit Test C++17, 82 kiểm thử app, 12 kịch bản T01–T12.</a:t>
             </a:r>
           </a:p>
         </p:txBody>
@@ -27486,7 +27452,7 @@
                 </a:solidFill>
                 <a:latin typeface="Segoe UI"/>
               </a:rPr>
-              <a:t>▸  Dữ liệu &amp; cảm biến: </a:t>
+              <a:t>▸  Tối ưu hệ thống: </a:t>
             </a:r>
             <a:r>
               <a:rPr sz="1140" b="0" i="0">
@@ -27495,7 +27461,7 @@
                 </a:solidFill>
                 <a:latin typeface="Segoe UI"/>
               </a:rPr>
-              <a:t>tinh chỉnh TinyML trên SisFall và dữ liệu dài ngày; thêm PPG MAX30102 (nhịp tim, SpO2).</a:t>
+              <a:t>mô hình TinyML, năng lượng/thời gian dùng pin và kích thước thiết bị.</a:t>
             </a:r>
           </a:p>
           <a:p>
@@ -27517,7 +27483,7 @@
                 </a:solidFill>
                 <a:latin typeface="Segoe UI"/>
               </a:rPr>
-              <a:t>▸  Kết nối &amp; vỏ: </a:t>
+              <a:t>▸  Đa dạng thiết bị: </a:t>
             </a:r>
             <a:r>
               <a:rPr sz="1140" b="0" i="0">
@@ -27526,7 +27492,7 @@
                 </a:solidFill>
                 <a:latin typeface="Segoe UI"/>
               </a:rPr>
-              <a:t>4G LTE / NB-IoT + GPS khi ra ngoài trời; vỏ in 3D chuẩn IP65.</a:t>
+              <a:t>trang bị hệ thống trên kính AI, đồng hồ thông minh, quần áo thông minh…</a:t>
             </a:r>
           </a:p>
           <a:p>
@@ -27548,7 +27514,7 @@
                 </a:solidFill>
                 <a:latin typeface="Segoe UI"/>
               </a:rPr>
-              <a:t>▸  Cầu nối Camera: </a:t>
+              <a:t>▸  Cảm biến &amp; kết nối: </a:t>
             </a:r>
             <a:r>
               <a:rPr sz="1140" b="0" i="0">
@@ -27557,7 +27523,7 @@
                 </a:solidFill>
                 <a:latin typeface="Segoe UI"/>
               </a:rPr>
-              <a:t>chuyển Relay/Telegram sang tác vụ FreeRTOS riêng để gói lặp UDP/BLE không bị hoãn.</a:t>
+              <a:t>PPG MAX30102 (nhịp tim, SpO2); 4G LTE / NB-IoT + GPS ngoài trời; vỏ in 3D IP65.</a:t>
             </a:r>
           </a:p>
           <a:p>
@@ -27579,7 +27545,7 @@
                 </a:solidFill>
                 <a:latin typeface="Segoe UI"/>
               </a:rPr>
-              <a:t>▸  Đo độ trễ thực tế: </a:t>
+              <a:t>▸  Cầu nối Camera: </a:t>
             </a:r>
             <a:r>
               <a:rPr sz="1140" b="0" i="0">
@@ -27588,7 +27554,7 @@
                 </a:solidFill>
                 <a:latin typeface="Segoe UI"/>
               </a:rPr>
-              <a:t>từng kênh UDP / BLE / Cloud / Telegram trên phần cứng và điện thoại thật.</a:t>
+              <a:t>chuyển Relay/Telegram sang tác vụ FreeRTOS riêng để gói lặp UDP/BLE không bị hoãn.</a:t>
             </a:r>
           </a:p>
           <a:p>
@@ -29226,7 +29192,7 @@
                 </a:solidFill>
                 <a:latin typeface="Segoe UI"/>
               </a:rPr>
-              <a:t>PSRAM tlsCalloc + TlsGate; đường truyền 5 lớp (UDP, BLE không chặn, thiết lập kết nối trước, Fast-Flush) và ứng dụng Flutter Android/iOS hợp nhất cảnh báo đa nguồn; 12/12 kịch bản T01–T12 đạt, 69 kiểm thử ứng dụng PASS.</a:t>
+              <a:t>PSRAM tlsCalloc + TlsGate; đường truyền 5 lớp (UDP, BLE không chặn, thiết lập kết nối trước, Fast-Flush) và ứng dụng Flutter Android/iOS hợp nhất cảnh báo đa nguồn; 12/12 kịch bản T01–T12 đạt, 82 kiểm thử ứng dụng PASS.</a:t>
             </a:r>
           </a:p>
         </p:txBody>

</xml_diff>